<commit_message>
proposal: rebuild Slide 5 as Product Architecture
Replace the old Slide 5 (Product / Service user-journey swimlane, which
duplicated the Solution slide's flow) with a Product Architecture slide
grounded in the new BRD (§11, §10) and TRD (§3).

- Render the three-tier trust split in Pitch-Deck-Official.pptx Slide 5:
  Client / Off-chain / On-chain (dark navy vault card), with the hero
  "releaser key" bridge arrow and four AP-tagged design-decision chips.
- Add proposal/product-architecture-slide.md (render-ready spec + 30s script).
- Revise Presentation(Old)/slide-05-product-service.md: repurpose to
  architecture, preserve the retired swimlane in a comment.
- Add build_slide5.py (reproducible slide generator) and a pre-edit backup.

Co-Authored-By: Claude Opus 4.8 <noreply@anthropic.com>
</commit_message>
<xml_diff>
--- a/proposal/Pitch-Deck-Official.pptx
+++ b/proposal/Pitch-Deck-Official.pptx
@@ -23245,16 +23245,8 @@
       </p:grpSpPr>
       <p:sp>
         <p:nvSpPr>
-          <p:cNvPr id="31" name="Rectangle 30">
-            <a:extLst>
-              <a:ext uri="{FF2B5EF4-FFF2-40B4-BE49-F238E27FC236}">
-                <a16:creationId xmlns:a16="http://schemas.microsoft.com/office/drawing/2014/main" id="{DF527E48-7C3F-4134-B177-CAE6BAA69174}"/>
-              </a:ext>
-            </a:extLst>
-          </p:cNvPr>
-          <p:cNvSpPr>
-            <a:spLocks noGrp="1"/>
-          </p:cNvSpPr>
+          <p:cNvPr id="41" name="bg"/>
+          <p:cNvSpPr/>
           <p:nvPr/>
         </p:nvSpPr>
         <p:spPr>
@@ -23287,16 +23279,8 @@
       </p:sp>
       <p:sp>
         <p:nvSpPr>
-          <p:cNvPr id="2" name="kicker-05-marker">
-            <a:extLst>
-              <a:ext uri="{FF2B5EF4-FFF2-40B4-BE49-F238E27FC236}">
-                <a16:creationId xmlns:a16="http://schemas.microsoft.com/office/drawing/2014/main" id="{DB21B6CC-1904-4F91-B45E-4090B2065634}"/>
-              </a:ext>
-            </a:extLst>
-          </p:cNvPr>
-          <p:cNvSpPr>
-            <a:spLocks noGrp="1"/>
-          </p:cNvSpPr>
+          <p:cNvPr id="42" name="kicker-marker"/>
+          <p:cNvSpPr/>
           <p:nvPr/>
         </p:nvSpPr>
         <p:spPr>
@@ -23329,16 +23313,8 @@
       </p:sp>
       <p:sp>
         <p:nvSpPr>
-          <p:cNvPr id="3" name="kicker-05-label">
-            <a:extLst>
-              <a:ext uri="{FF2B5EF4-FFF2-40B4-BE49-F238E27FC236}">
-                <a16:creationId xmlns:a16="http://schemas.microsoft.com/office/drawing/2014/main" id="{26993B88-157F-46AD-854B-0DF5E534682C}"/>
-              </a:ext>
-            </a:extLst>
-          </p:cNvPr>
-          <p:cNvSpPr>
-            <a:spLocks noGrp="1"/>
-          </p:cNvSpPr>
+          <p:cNvPr id="43" name="kicker"/>
+          <p:cNvSpPr/>
           <p:nvPr/>
         </p:nvSpPr>
         <p:spPr>
@@ -23364,51 +23340,36 @@
           </a:ln>
         </p:spPr>
         <p:txBody>
-          <a:bodyPr lIns="0" tIns="0" rIns="0" bIns="0" anchor="ctr"/>
-          <a:lstStyle/>
-          <a:p>
-            <a:pPr algn="l">
-              <a:defRPr sz="900" b="1">
+          <a:bodyPr lIns="0" tIns="0" rIns="0" bIns="0" anchor="ctr" wrap="square">
+            <a:normAutofit/>
+          </a:bodyPr>
+          <a:lstStyle/>
+          <a:p>
+            <a:pPr algn="l"/>
+            <a:r>
+              <a:rPr sz="900" b="1">
                 <a:solidFill>
                   <a:srgbClr val="6B7280"/>
                 </a:solidFill>
                 <a:latin typeface="Aptos"/>
                 <a:ea typeface="Aptos"/>
                 <a:cs typeface="Aptos"/>
-              </a:defRPr>
-            </a:pPr>
-            <a:r>
-              <a:rPr sz="900" b="1">
-                <a:solidFill>
-                  <a:srgbClr val="6B7280"/>
-                </a:solidFill>
-                <a:latin typeface="Aptos"/>
-                <a:ea typeface="Aptos"/>
-                <a:cs typeface="Aptos"/>
-              </a:rPr>
-              <a:t>PRODUCT</a:t>
-            </a:r>
-          </a:p>
-        </p:txBody>
-      </p:sp>
-      <p:sp>
-        <p:nvSpPr>
-          <p:cNvPr id="4" name="Rectangle 3">
-            <a:extLst>
-              <a:ext uri="{FF2B5EF4-FFF2-40B4-BE49-F238E27FC236}">
-                <a16:creationId xmlns:a16="http://schemas.microsoft.com/office/drawing/2014/main" id="{4459BFF0-9D04-4E24-9284-AED08DB7959C}"/>
-              </a:ext>
-            </a:extLst>
-          </p:cNvPr>
-          <p:cNvSpPr>
-            <a:spLocks noGrp="1"/>
-          </p:cNvSpPr>
+              </a:rPr>
+              <a:t>PRODUCT ARCHITECTURE</a:t>
+            </a:r>
+          </a:p>
+        </p:txBody>
+      </p:sp>
+      <p:sp>
+        <p:nvSpPr>
+          <p:cNvPr id="44" name="title"/>
+          <p:cNvSpPr/>
           <p:nvPr/>
         </p:nvSpPr>
         <p:spPr>
           <a:xfrm>
             <a:off x="533400" y="685800"/>
-            <a:ext cx="8191500" cy="876300"/>
+            <a:ext cx="11125200" cy="900000"/>
           </a:xfrm>
           <a:prstGeom prst="rect">
             <a:avLst/>
@@ -23428,51 +23389,36 @@
           </a:ln>
         </p:spPr>
         <p:txBody>
-          <a:bodyPr lIns="0" tIns="0" rIns="0" bIns="0" anchor="t"/>
-          <a:lstStyle/>
-          <a:p>
-            <a:pPr algn="l">
-              <a:defRPr sz="3000" b="1">
+          <a:bodyPr lIns="0" tIns="0" rIns="0" bIns="0" anchor="t" wrap="square">
+            <a:normAutofit/>
+          </a:bodyPr>
+          <a:lstStyle/>
+          <a:p>
+            <a:pPr algn="l"/>
+            <a:r>
+              <a:rPr sz="3000" b="1">
                 <a:solidFill>
                   <a:srgbClr val="0B1B3A"/>
                 </a:solidFill>
                 <a:latin typeface="Aptos Display"/>
                 <a:ea typeface="Aptos Display"/>
                 <a:cs typeface="Aptos Display"/>
-              </a:defRPr>
-            </a:pPr>
-            <a:r>
-              <a:rPr sz="3000" b="1">
-                <a:solidFill>
-                  <a:srgbClr val="0B1B3A"/>
-                </a:solidFill>
-                <a:latin typeface="Aptos Display"/>
-                <a:ea typeface="Aptos Display"/>
-                <a:cs typeface="Aptos Display"/>
-              </a:rPr>
-              <a:t>The MVP is governed documentary escrow, not a generic admin release button.</a:t>
-            </a:r>
-          </a:p>
-        </p:txBody>
-      </p:sp>
-      <p:sp>
-        <p:nvSpPr>
-          <p:cNvPr id="5" name="Rectangle 4">
-            <a:extLst>
-              <a:ext uri="{FF2B5EF4-FFF2-40B4-BE49-F238E27FC236}">
-                <a16:creationId xmlns:a16="http://schemas.microsoft.com/office/drawing/2014/main" id="{03766352-FB2D-4AEC-A481-659F7255E98D}"/>
-              </a:ext>
-            </a:extLst>
-          </p:cNvPr>
-          <p:cNvSpPr>
-            <a:spLocks noGrp="1"/>
-          </p:cNvSpPr>
-          <p:nvPr/>
-        </p:nvSpPr>
-        <p:spPr>
-          <a:xfrm>
-            <a:off x="571500" y="1638300"/>
-            <a:ext cx="7048500" cy="495300"/>
+              </a:rPr>
+              <a:t>Three trust tiers — narrow on-chain, smart off-chain, one bridge between.</a:t>
+            </a:r>
+          </a:p>
+        </p:txBody>
+      </p:sp>
+      <p:sp>
+        <p:nvSpPr>
+          <p:cNvPr id="45" name="subhead"/>
+          <p:cNvSpPr/>
+          <p:nvPr/>
+        </p:nvSpPr>
+        <p:spPr>
+          <a:xfrm>
+            <a:off x="533400" y="1670000"/>
+            <a:ext cx="11125200" cy="420000"/>
           </a:xfrm>
           <a:prstGeom prst="rect">
             <a:avLst/>
@@ -23492,61 +23438,46 @@
           </a:ln>
         </p:spPr>
         <p:txBody>
-          <a:bodyPr lIns="0" tIns="0" rIns="0" bIns="0" anchor="t"/>
-          <a:lstStyle/>
-          <a:p>
-            <a:pPr algn="l">
-              <a:defRPr sz="1500" b="0">
+          <a:bodyPr lIns="0" tIns="0" rIns="0" bIns="0" anchor="t" wrap="square">
+            <a:normAutofit/>
+          </a:bodyPr>
+          <a:lstStyle/>
+          <a:p>
+            <a:pPr algn="l"/>
+            <a:r>
+              <a:rPr sz="1400" b="0">
                 <a:solidFill>
                   <a:srgbClr val="1B2430"/>
                 </a:solidFill>
                 <a:latin typeface="Aptos"/>
                 <a:ea typeface="Aptos"/>
                 <a:cs typeface="Aptos"/>
-              </a:defRPr>
-            </a:pPr>
-            <a:r>
-              <a:rPr sz="1500" b="0">
-                <a:solidFill>
-                  <a:srgbClr val="1B2430"/>
-                </a:solidFill>
-                <a:latin typeface="Aptos"/>
-                <a:ea typeface="Aptos"/>
-                <a:cs typeface="Aptos"/>
-              </a:rPr>
-              <a:t>Blockmediary makes the release rules explicit before funds move. The signed Escrow Specification becomes the operational source of truth.</a:t>
-            </a:r>
-          </a:p>
-        </p:txBody>
-      </p:sp>
-      <p:sp>
-        <p:nvSpPr>
-          <p:cNvPr id="6" name="Rectangle 5">
-            <a:extLst>
-              <a:ext uri="{FF2B5EF4-FFF2-40B4-BE49-F238E27FC236}">
-                <a16:creationId xmlns:a16="http://schemas.microsoft.com/office/drawing/2014/main" id="{9191D52C-7145-4AA0-9014-E2BD9B997EBA}"/>
-              </a:ext>
-            </a:extLst>
-          </p:cNvPr>
-          <p:cNvSpPr>
-            <a:spLocks noGrp="1"/>
-          </p:cNvSpPr>
-          <p:nvPr/>
-        </p:nvSpPr>
-        <p:spPr>
-          <a:xfrm>
-            <a:off x="666750" y="2686050"/>
-            <a:ext cx="2333625" cy="876300"/>
-          </a:xfrm>
-          <a:prstGeom prst="rect">
-            <a:avLst/>
-          </a:prstGeom>
-          <a:solidFill>
-            <a:srgbClr val="E8E5F8"/>
+              </a:rPr>
+              <a:t>The smart contract never sees a document — it holds funds and enforces state. All verification is off-chain; one authorised releaser key is the only path to on-chain money.</a:t>
+            </a:r>
+          </a:p>
+        </p:txBody>
+      </p:sp>
+      <p:sp>
+        <p:nvSpPr>
+          <p:cNvPr id="46" name="tier-card"/>
+          <p:cNvSpPr/>
+          <p:nvPr/>
+        </p:nvSpPr>
+        <p:spPr>
+          <a:xfrm>
+            <a:off x="533400" y="2120000"/>
+            <a:ext cx="6300000" cy="980000"/>
+          </a:xfrm>
+          <a:prstGeom prst="rect">
+            <a:avLst/>
+          </a:prstGeom>
+          <a:solidFill>
+            <a:srgbClr val="DDEAF5"/>
           </a:solidFill>
           <a:ln w="9525">
             <a:solidFill>
-              <a:srgbClr val="5A4FBF"/>
+              <a:srgbClr val="1F6FB2"/>
             </a:solidFill>
             <a:prstDash val="solid"/>
           </a:ln>
@@ -23561,28 +23492,20 @@
       </p:sp>
       <p:sp>
         <p:nvSpPr>
-          <p:cNvPr id="7" name="Rectangle 6">
-            <a:extLst>
-              <a:ext uri="{FF2B5EF4-FFF2-40B4-BE49-F238E27FC236}">
-                <a16:creationId xmlns:a16="http://schemas.microsoft.com/office/drawing/2014/main" id="{67A52728-5221-43AC-B438-C8CCAFBA1734}"/>
-              </a:ext>
-            </a:extLst>
-          </p:cNvPr>
-          <p:cNvSpPr>
-            <a:spLocks noGrp="1"/>
-          </p:cNvSpPr>
-          <p:nvPr/>
-        </p:nvSpPr>
-        <p:spPr>
-          <a:xfrm>
-            <a:off x="666750" y="2686050"/>
-            <a:ext cx="57150" cy="876300"/>
-          </a:xfrm>
-          <a:prstGeom prst="rect">
-            <a:avLst/>
-          </a:prstGeom>
-          <a:solidFill>
-            <a:srgbClr val="5A4FBF"/>
+          <p:cNvPr id="47" name="tier-bar"/>
+          <p:cNvSpPr/>
+          <p:nvPr/>
+        </p:nvSpPr>
+        <p:spPr>
+          <a:xfrm>
+            <a:off x="533400" y="2120000"/>
+            <a:ext cx="57150" cy="980000"/>
+          </a:xfrm>
+          <a:prstGeom prst="rect">
+            <a:avLst/>
+          </a:prstGeom>
+          <a:solidFill>
+            <a:srgbClr val="1F6FB2"/>
           </a:solidFill>
           <a:ln w="0">
             <a:solidFill>
@@ -23603,22 +23526,14 @@
       </p:sp>
       <p:sp>
         <p:nvSpPr>
-          <p:cNvPr id="8" name="Rectangle 7">
-            <a:extLst>
-              <a:ext uri="{FF2B5EF4-FFF2-40B4-BE49-F238E27FC236}">
-                <a16:creationId xmlns:a16="http://schemas.microsoft.com/office/drawing/2014/main" id="{BB7D500E-97C7-422F-B02D-F7CB22068ACD}"/>
-              </a:ext>
-            </a:extLst>
-          </p:cNvPr>
-          <p:cNvSpPr>
-            <a:spLocks noGrp="1"/>
-          </p:cNvSpPr>
-          <p:nvPr/>
-        </p:nvSpPr>
-        <p:spPr>
-          <a:xfrm>
-            <a:off x="857250" y="2819400"/>
-            <a:ext cx="1905000" cy="209550"/>
+          <p:cNvPr id="48" name="tier-txt"/>
+          <p:cNvSpPr/>
+          <p:nvPr/>
+        </p:nvSpPr>
+        <p:spPr>
+          <a:xfrm>
+            <a:off x="723900" y="2240000"/>
+            <a:ext cx="5959500" cy="780000"/>
           </a:xfrm>
           <a:prstGeom prst="rect">
             <a:avLst/>
@@ -23638,51 +23553,87 @@
           </a:ln>
         </p:spPr>
         <p:txBody>
-          <a:bodyPr lIns="0" tIns="0" rIns="0" bIns="0" anchor="t"/>
-          <a:lstStyle/>
+          <a:bodyPr lIns="0" tIns="0" rIns="0" bIns="0" anchor="ctr" wrap="square">
+            <a:normAutofit/>
+          </a:bodyPr>
+          <a:lstStyle/>
+          <a:p>
+            <a:pPr algn="l"/>
+            <a:r>
+              <a:rPr sz="1250" b="1">
+                <a:solidFill>
+                  <a:srgbClr val="0B1B3A"/>
+                </a:solidFill>
+                <a:latin typeface="Aptos"/>
+                <a:ea typeface="Aptos"/>
+                <a:cs typeface="Aptos"/>
+              </a:rPr>
+              <a:t>CLIENT TIER  ·  Buyer · Seller · Reviewer</a:t>
+            </a:r>
+          </a:p>
           <a:p>
             <a:pPr algn="l">
-              <a:defRPr sz="1200" b="1">
-                <a:solidFill>
-                  <a:srgbClr val="0B1B3A"/>
-                </a:solidFill>
-                <a:latin typeface="Aptos"/>
-                <a:ea typeface="Aptos"/>
-                <a:cs typeface="Aptos"/>
-              </a:defRPr>
+              <a:spcBef>
+                <a:spcPts val="300"/>
+              </a:spcBef>
             </a:pPr>
             <a:r>
-              <a:rPr sz="1200" b="1">
-                <a:solidFill>
-                  <a:srgbClr val="0B1B3A"/>
-                </a:solidFill>
-                <a:latin typeface="Aptos"/>
-                <a:ea typeface="Aptos"/>
-                <a:cs typeface="Aptos"/>
-              </a:rPr>
-              <a:t>1. Escrow Specification</a:t>
-            </a:r>
-          </a:p>
-        </p:txBody>
-      </p:sp>
-      <p:sp>
-        <p:nvSpPr>
-          <p:cNvPr id="9" name="Rectangle 8">
-            <a:extLst>
-              <a:ext uri="{FF2B5EF4-FFF2-40B4-BE49-F238E27FC236}">
-                <a16:creationId xmlns:a16="http://schemas.microsoft.com/office/drawing/2014/main" id="{9C129E90-3155-4A06-AF1D-9E3812B3206E}"/>
-              </a:ext>
-            </a:extLst>
-          </p:cNvPr>
-          <p:cNvSpPr>
-            <a:spLocks noGrp="1"/>
-          </p:cNvSpPr>
-          <p:nvPr/>
-        </p:nvSpPr>
-        <p:spPr>
-          <a:xfrm>
-            <a:off x="857250" y="3086100"/>
-            <a:ext cx="1905000" cy="323850"/>
+              <a:rPr sz="1000" b="0">
+                <a:solidFill>
+                  <a:srgbClr val="6B7280"/>
+                </a:solidFill>
+                <a:latin typeface="Aptos"/>
+                <a:ea typeface="Aptos"/>
+                <a:cs typeface="Aptos"/>
+              </a:rPr>
+              <a:t>Every read/write goes through one authenticated API. Wallets sign deposit / release straight to the chain.</a:t>
+            </a:r>
+          </a:p>
+        </p:txBody>
+      </p:sp>
+      <p:sp>
+        <p:nvSpPr>
+          <p:cNvPr id="49" name="conn1-arrow"/>
+          <p:cNvSpPr/>
+          <p:nvPr/>
+        </p:nvSpPr>
+        <p:spPr>
+          <a:xfrm>
+            <a:off x="900000" y="3130000"/>
+            <a:ext cx="228600" cy="240000"/>
+          </a:xfrm>
+          <a:prstGeom prst="downArrow">
+            <a:avLst/>
+          </a:prstGeom>
+          <a:solidFill>
+            <a:srgbClr val="6B7280"/>
+          </a:solidFill>
+          <a:ln w="0">
+            <a:solidFill>
+              <a:srgbClr val="000000">
+                <a:alpha val="0"/>
+              </a:srgbClr>
+            </a:solidFill>
+          </a:ln>
+        </p:spPr>
+        <p:txBody>
+          <a:bodyPr/>
+          <a:lstStyle/>
+          <a:p>
+            <a:endParaRPr/>
+          </a:p>
+        </p:txBody>
+      </p:sp>
+      <p:sp>
+        <p:nvSpPr>
+          <p:cNvPr id="50" name="conn1-label"/>
+          <p:cNvSpPr/>
+          <p:nvPr/>
+        </p:nvSpPr>
+        <p:spPr>
+          <a:xfrm>
+            <a:off x="1230000" y="3150000"/>
+            <a:ext cx="5400000" cy="240000"/>
           </a:xfrm>
           <a:prstGeom prst="rect">
             <a:avLst/>
@@ -23702,51 +23653,36 @@
           </a:ln>
         </p:spPr>
         <p:txBody>
-          <a:bodyPr lIns="0" tIns="0" rIns="0" bIns="0" anchor="t"/>
-          <a:lstStyle/>
-          <a:p>
-            <a:pPr algn="l">
-              <a:defRPr sz="938" b="0">
+          <a:bodyPr lIns="0" tIns="0" rIns="0" bIns="0" anchor="ctr" wrap="square">
+            <a:normAutofit/>
+          </a:bodyPr>
+          <a:lstStyle/>
+          <a:p>
+            <a:pPr algn="l"/>
+            <a:r>
+              <a:rPr sz="950" b="1">
                 <a:solidFill>
                   <a:srgbClr val="6B7280"/>
                 </a:solidFill>
                 <a:latin typeface="Aptos"/>
                 <a:ea typeface="Aptos"/>
                 <a:cs typeface="Aptos"/>
-              </a:defRPr>
-            </a:pPr>
-            <a:r>
-              <a:rPr sz="938" b="0">
-                <a:solidFill>
-                  <a:srgbClr val="6B7280"/>
-                </a:solidFill>
-                <a:latin typeface="Aptos"/>
-                <a:ea typeface="Aptos"/>
-                <a:cs typeface="Aptos"/>
-              </a:rPr>
-              <a:t>Structured trade terms, required documents, objection window, release rules.</a:t>
-            </a:r>
-          </a:p>
-        </p:txBody>
-      </p:sp>
-      <p:sp>
-        <p:nvSpPr>
-          <p:cNvPr id="10" name="Rectangle 9">
-            <a:extLst>
-              <a:ext uri="{FF2B5EF4-FFF2-40B4-BE49-F238E27FC236}">
-                <a16:creationId xmlns:a16="http://schemas.microsoft.com/office/drawing/2014/main" id="{0A363E27-A425-4D6D-AA20-C36A44B02799}"/>
-              </a:ext>
-            </a:extLst>
-          </p:cNvPr>
-          <p:cNvSpPr>
-            <a:spLocks noGrp="1"/>
-          </p:cNvSpPr>
-          <p:nvPr/>
-        </p:nvSpPr>
-        <p:spPr>
-          <a:xfrm>
-            <a:off x="3429000" y="2686050"/>
-            <a:ext cx="2333625" cy="876300"/>
+              </a:rPr>
+              <a:t>HTTPS · all app data via the authenticated API  (full API integration)</a:t>
+            </a:r>
+          </a:p>
+        </p:txBody>
+      </p:sp>
+      <p:sp>
+        <p:nvSpPr>
+          <p:cNvPr id="51" name="tier-card"/>
+          <p:cNvSpPr/>
+          <p:nvPr/>
+        </p:nvSpPr>
+        <p:spPr>
+          <a:xfrm>
+            <a:off x="533400" y="3400000"/>
+            <a:ext cx="6300000" cy="1330000"/>
           </a:xfrm>
           <a:prstGeom prst="rect">
             <a:avLst/>
@@ -23771,22 +23707,14 @@
       </p:sp>
       <p:sp>
         <p:nvSpPr>
-          <p:cNvPr id="11" name="Rectangle 10">
-            <a:extLst>
-              <a:ext uri="{FF2B5EF4-FFF2-40B4-BE49-F238E27FC236}">
-                <a16:creationId xmlns:a16="http://schemas.microsoft.com/office/drawing/2014/main" id="{2345E463-9069-4BC5-8E63-AE909E46C09D}"/>
-              </a:ext>
-            </a:extLst>
-          </p:cNvPr>
-          <p:cNvSpPr>
-            <a:spLocks noGrp="1"/>
-          </p:cNvSpPr>
-          <p:nvPr/>
-        </p:nvSpPr>
-        <p:spPr>
-          <a:xfrm>
-            <a:off x="3429000" y="2686050"/>
-            <a:ext cx="57150" cy="876300"/>
+          <p:cNvPr id="52" name="tier-bar"/>
+          <p:cNvSpPr/>
+          <p:nvPr/>
+        </p:nvSpPr>
+        <p:spPr>
+          <a:xfrm>
+            <a:off x="533400" y="3400000"/>
+            <a:ext cx="57150" cy="1330000"/>
           </a:xfrm>
           <a:prstGeom prst="rect">
             <a:avLst/>
@@ -23813,22 +23741,14 @@
       </p:sp>
       <p:sp>
         <p:nvSpPr>
-          <p:cNvPr id="12" name="Rectangle 11">
-            <a:extLst>
-              <a:ext uri="{FF2B5EF4-FFF2-40B4-BE49-F238E27FC236}">
-                <a16:creationId xmlns:a16="http://schemas.microsoft.com/office/drawing/2014/main" id="{3A52CB99-0B7F-4E77-965C-3D6638F7ECCD}"/>
-              </a:ext>
-            </a:extLst>
-          </p:cNvPr>
-          <p:cNvSpPr>
-            <a:spLocks noGrp="1"/>
-          </p:cNvSpPr>
-          <p:nvPr/>
-        </p:nvSpPr>
-        <p:spPr>
-          <a:xfrm>
-            <a:off x="3619500" y="2819400"/>
-            <a:ext cx="1905000" cy="209550"/>
+          <p:cNvPr id="53" name="tier-txt"/>
+          <p:cNvSpPr/>
+          <p:nvPr/>
+        </p:nvSpPr>
+        <p:spPr>
+          <a:xfrm>
+            <a:off x="723900" y="3520000"/>
+            <a:ext cx="5959500" cy="1130000"/>
           </a:xfrm>
           <a:prstGeom prst="rect">
             <a:avLst/>
@@ -23848,51 +23768,87 @@
           </a:ln>
         </p:spPr>
         <p:txBody>
-          <a:bodyPr lIns="0" tIns="0" rIns="0" bIns="0" anchor="t"/>
-          <a:lstStyle/>
+          <a:bodyPr lIns="0" tIns="0" rIns="0" bIns="0" anchor="ctr" wrap="square">
+            <a:normAutofit/>
+          </a:bodyPr>
+          <a:lstStyle/>
+          <a:p>
+            <a:pPr algn="l"/>
+            <a:r>
+              <a:rPr sz="1250" b="1">
+                <a:solidFill>
+                  <a:srgbClr val="0B1B3A"/>
+                </a:solidFill>
+                <a:latin typeface="Aptos"/>
+                <a:ea typeface="Aptos"/>
+                <a:cs typeface="Aptos"/>
+              </a:rPr>
+              <a:t>OFF-CHAIN ORCHESTRATION + VERIFICATION</a:t>
+            </a:r>
+          </a:p>
           <a:p>
             <a:pPr algn="l">
-              <a:defRPr sz="1200" b="1">
-                <a:solidFill>
-                  <a:srgbClr val="0B1B3A"/>
-                </a:solidFill>
-                <a:latin typeface="Aptos"/>
-                <a:ea typeface="Aptos"/>
-                <a:cs typeface="Aptos"/>
-              </a:defRPr>
+              <a:spcBef>
+                <a:spcPts val="300"/>
+              </a:spcBef>
             </a:pPr>
             <a:r>
-              <a:rPr sz="1200" b="1">
-                <a:solidFill>
-                  <a:srgbClr val="0B1B3A"/>
-                </a:solidFill>
-                <a:latin typeface="Aptos"/>
-                <a:ea typeface="Aptos"/>
-                <a:cs typeface="Aptos"/>
-              </a:rPr>
-              <a:t>2. Trade Escrow Agreement</a:t>
-            </a:r>
-          </a:p>
-        </p:txBody>
-      </p:sp>
-      <p:sp>
-        <p:nvSpPr>
-          <p:cNvPr id="13" name="Rectangle 12">
-            <a:extLst>
-              <a:ext uri="{FF2B5EF4-FFF2-40B4-BE49-F238E27FC236}">
-                <a16:creationId xmlns:a16="http://schemas.microsoft.com/office/drawing/2014/main" id="{FF74D830-9A9D-49D7-8194-B82350217F97}"/>
-              </a:ext>
-            </a:extLst>
-          </p:cNvPr>
-          <p:cNvSpPr>
-            <a:spLocks noGrp="1"/>
-          </p:cNvSpPr>
-          <p:nvPr/>
-        </p:nvSpPr>
-        <p:spPr>
-          <a:xfrm>
-            <a:off x="3619500" y="3086100"/>
-            <a:ext cx="1905000" cy="323850"/>
+              <a:rPr sz="1000" b="0">
+                <a:solidFill>
+                  <a:srgbClr val="6B7280"/>
+                </a:solidFill>
+                <a:latin typeface="Aptos"/>
+                <a:ea typeface="Aptos"/>
+                <a:cs typeface="Aptos"/>
+              </a:rPr>
+              <a:t>deal-intake · KYC / sanctions · document-checker + rules engine · dispute · settlement. AI reads, deterministic code computes the money, a human signs off. The append-only audit ledger is the regulator-facing source of truth.</a:t>
+            </a:r>
+          </a:p>
+        </p:txBody>
+      </p:sp>
+      <p:sp>
+        <p:nvSpPr>
+          <p:cNvPr id="54" name="bridge-arrow"/>
+          <p:cNvSpPr/>
+          <p:nvPr/>
+        </p:nvSpPr>
+        <p:spPr>
+          <a:xfrm>
+            <a:off x="880000" y="4760000"/>
+            <a:ext cx="300000" cy="310000"/>
+          </a:xfrm>
+          <a:prstGeom prst="downArrow">
+            <a:avLst/>
+          </a:prstGeom>
+          <a:solidFill>
+            <a:srgbClr val="0B1B3A"/>
+          </a:solidFill>
+          <a:ln w="0">
+            <a:solidFill>
+              <a:srgbClr val="000000">
+                <a:alpha val="0"/>
+              </a:srgbClr>
+            </a:solidFill>
+          </a:ln>
+        </p:spPr>
+        <p:txBody>
+          <a:bodyPr/>
+          <a:lstStyle/>
+          <a:p>
+            <a:endParaRPr/>
+          </a:p>
+        </p:txBody>
+      </p:sp>
+      <p:sp>
+        <p:nvSpPr>
+          <p:cNvPr id="55" name="bridge-label"/>
+          <p:cNvSpPr/>
+          <p:nvPr/>
+        </p:nvSpPr>
+        <p:spPr>
+          <a:xfrm>
+            <a:off x="1260000" y="4790000"/>
+            <a:ext cx="5350000" cy="260000"/>
           </a:xfrm>
           <a:prstGeom prst="rect">
             <a:avLst/>
@@ -23912,61 +23868,46 @@
           </a:ln>
         </p:spPr>
         <p:txBody>
-          <a:bodyPr lIns="0" tIns="0" rIns="0" bIns="0" anchor="t"/>
-          <a:lstStyle/>
-          <a:p>
-            <a:pPr algn="l">
-              <a:defRPr sz="938" b="0">
-                <a:solidFill>
-                  <a:srgbClr val="6B7280"/>
-                </a:solidFill>
-                <a:latin typeface="Aptos"/>
-                <a:ea typeface="Aptos"/>
-                <a:cs typeface="Aptos"/>
-              </a:defRPr>
-            </a:pPr>
-            <a:r>
-              <a:rPr sz="938" b="0">
-                <a:solidFill>
-                  <a:srgbClr val="6B7280"/>
-                </a:solidFill>
-                <a:latin typeface="Aptos"/>
-                <a:ea typeface="Aptos"/>
-                <a:cs typeface="Aptos"/>
-              </a:rPr>
-              <a:t>Buyer and seller accept the payment-release workflow and dispute path.</a:t>
-            </a:r>
-          </a:p>
-        </p:txBody>
-      </p:sp>
-      <p:sp>
-        <p:nvSpPr>
-          <p:cNvPr id="14" name="Rectangle 13">
-            <a:extLst>
-              <a:ext uri="{FF2B5EF4-FFF2-40B4-BE49-F238E27FC236}">
-                <a16:creationId xmlns:a16="http://schemas.microsoft.com/office/drawing/2014/main" id="{8D55A71B-0C0B-4F9C-8D0B-6F0E548C39D9}"/>
-              </a:ext>
-            </a:extLst>
-          </p:cNvPr>
-          <p:cNvSpPr>
-            <a:spLocks noGrp="1"/>
-          </p:cNvSpPr>
-          <p:nvPr/>
-        </p:nvSpPr>
-        <p:spPr>
-          <a:xfrm>
-            <a:off x="6191250" y="2686050"/>
-            <a:ext cx="2333625" cy="876300"/>
-          </a:xfrm>
-          <a:prstGeom prst="rect">
-            <a:avLst/>
-          </a:prstGeom>
-          <a:solidFill>
-            <a:srgbClr val="DDEAF5"/>
+          <a:bodyPr lIns="0" tIns="0" rIns="0" bIns="0" anchor="ctr" wrap="square">
+            <a:normAutofit/>
+          </a:bodyPr>
+          <a:lstStyle/>
+          <a:p>
+            <a:pPr algn="l"/>
+            <a:r>
+              <a:rPr sz="1000" b="1">
+                <a:solidFill>
+                  <a:srgbClr val="0B1B3A"/>
+                </a:solidFill>
+                <a:latin typeface="Aptos"/>
+                <a:ea typeface="Aptos"/>
+                <a:cs typeface="Aptos"/>
+              </a:rPr>
+              <a:t>releaser key — the ONE bridge:  off-chain verdict → recordVerdict on-chain</a:t>
+            </a:r>
+          </a:p>
+        </p:txBody>
+      </p:sp>
+      <p:sp>
+        <p:nvSpPr>
+          <p:cNvPr id="56" name="tier-card"/>
+          <p:cNvSpPr/>
+          <p:nvPr/>
+        </p:nvSpPr>
+        <p:spPr>
+          <a:xfrm>
+            <a:off x="533400" y="5090000"/>
+            <a:ext cx="6300000" cy="980000"/>
+          </a:xfrm>
+          <a:prstGeom prst="rect">
+            <a:avLst/>
+          </a:prstGeom>
+          <a:solidFill>
+            <a:srgbClr val="0B1B3A"/>
           </a:solidFill>
           <a:ln w="9525">
             <a:solidFill>
-              <a:srgbClr val="1F6FB2"/>
+              <a:srgbClr val="0B1B3A"/>
             </a:solidFill>
             <a:prstDash val="solid"/>
           </a:ln>
@@ -23981,28 +23922,20 @@
       </p:sp>
       <p:sp>
         <p:nvSpPr>
-          <p:cNvPr id="15" name="Rectangle 14">
-            <a:extLst>
-              <a:ext uri="{FF2B5EF4-FFF2-40B4-BE49-F238E27FC236}">
-                <a16:creationId xmlns:a16="http://schemas.microsoft.com/office/drawing/2014/main" id="{3A382483-E0A2-4A16-89FC-C7BA9D143129}"/>
-              </a:ext>
-            </a:extLst>
-          </p:cNvPr>
-          <p:cNvSpPr>
-            <a:spLocks noGrp="1"/>
-          </p:cNvSpPr>
-          <p:nvPr/>
-        </p:nvSpPr>
-        <p:spPr>
-          <a:xfrm>
-            <a:off x="6191250" y="2686050"/>
-            <a:ext cx="57150" cy="876300"/>
-          </a:xfrm>
-          <a:prstGeom prst="rect">
-            <a:avLst/>
-          </a:prstGeom>
-          <a:solidFill>
-            <a:srgbClr val="1F6FB2"/>
+          <p:cNvPr id="57" name="tier-bar"/>
+          <p:cNvSpPr/>
+          <p:nvPr/>
+        </p:nvSpPr>
+        <p:spPr>
+          <a:xfrm>
+            <a:off x="533400" y="5090000"/>
+            <a:ext cx="57150" cy="980000"/>
+          </a:xfrm>
+          <a:prstGeom prst="rect">
+            <a:avLst/>
+          </a:prstGeom>
+          <a:solidFill>
+            <a:srgbClr val="0B1B3A"/>
           </a:solidFill>
           <a:ln w="0">
             <a:solidFill>
@@ -24023,22 +23956,14 @@
       </p:sp>
       <p:sp>
         <p:nvSpPr>
-          <p:cNvPr id="16" name="Rectangle 15">
-            <a:extLst>
-              <a:ext uri="{FF2B5EF4-FFF2-40B4-BE49-F238E27FC236}">
-                <a16:creationId xmlns:a16="http://schemas.microsoft.com/office/drawing/2014/main" id="{48E970C4-0FBD-44E1-95B2-01B86BF60772}"/>
-              </a:ext>
-            </a:extLst>
-          </p:cNvPr>
-          <p:cNvSpPr>
-            <a:spLocks noGrp="1"/>
-          </p:cNvSpPr>
-          <p:nvPr/>
-        </p:nvSpPr>
-        <p:spPr>
-          <a:xfrm>
-            <a:off x="6381750" y="2819400"/>
-            <a:ext cx="1905000" cy="209550"/>
+          <p:cNvPr id="58" name="tier-txt"/>
+          <p:cNvSpPr/>
+          <p:nvPr/>
+        </p:nvSpPr>
+        <p:spPr>
+          <a:xfrm>
+            <a:off x="723900" y="5210000"/>
+            <a:ext cx="5959500" cy="780000"/>
           </a:xfrm>
           <a:prstGeom prst="rect">
             <a:avLst/>
@@ -24058,51 +23983,54 @@
           </a:ln>
         </p:spPr>
         <p:txBody>
-          <a:bodyPr lIns="0" tIns="0" rIns="0" bIns="0" anchor="t"/>
-          <a:lstStyle/>
+          <a:bodyPr lIns="0" tIns="0" rIns="0" bIns="0" anchor="ctr" wrap="square">
+            <a:normAutofit/>
+          </a:bodyPr>
+          <a:lstStyle/>
+          <a:p>
+            <a:pPr algn="l"/>
+            <a:r>
+              <a:rPr sz="1250" b="1">
+                <a:solidFill>
+                  <a:srgbClr val="FFFFFF"/>
+                </a:solidFill>
+                <a:latin typeface="Aptos"/>
+                <a:ea typeface="Aptos"/>
+                <a:cs typeface="Aptos"/>
+              </a:rPr>
+              <a:t>ON-CHAIN TIER  ·  narrow Escrow contract  ·  Base Sepolia (EVM L2)</a:t>
+            </a:r>
+          </a:p>
           <a:p>
             <a:pPr algn="l">
-              <a:defRPr sz="1200" b="1">
-                <a:solidFill>
-                  <a:srgbClr val="0B1B3A"/>
-                </a:solidFill>
-                <a:latin typeface="Aptos"/>
-                <a:ea typeface="Aptos"/>
-                <a:cs typeface="Aptos"/>
-              </a:defRPr>
+              <a:spcBef>
+                <a:spcPts val="300"/>
+              </a:spcBef>
             </a:pPr>
             <a:r>
-              <a:rPr sz="1200" b="1">
-                <a:solidFill>
-                  <a:srgbClr val="0B1B3A"/>
-                </a:solidFill>
-                <a:latin typeface="Aptos"/>
-                <a:ea typeface="Aptos"/>
-                <a:cs typeface="Aptos"/>
-              </a:rPr>
-              <a:t>3. Submitted Documents</a:t>
-            </a:r>
-          </a:p>
-        </p:txBody>
-      </p:sp>
-      <p:sp>
-        <p:nvSpPr>
-          <p:cNvPr id="17" name="Rectangle 16">
-            <a:extLst>
-              <a:ext uri="{FF2B5EF4-FFF2-40B4-BE49-F238E27FC236}">
-                <a16:creationId xmlns:a16="http://schemas.microsoft.com/office/drawing/2014/main" id="{4DC92CAA-524D-42C8-BF3C-1CF88A37564D}"/>
-              </a:ext>
-            </a:extLst>
-          </p:cNvPr>
-          <p:cNvSpPr>
-            <a:spLocks noGrp="1"/>
-          </p:cNvSpPr>
-          <p:nvPr/>
-        </p:nvSpPr>
-        <p:spPr>
-          <a:xfrm>
-            <a:off x="6381750" y="3086100"/>
-            <a:ext cx="1905000" cy="323850"/>
+              <a:rPr sz="1000" b="0">
+                <a:solidFill>
+                  <a:srgbClr val="CADCFC"/>
+                </a:solidFill>
+                <a:latin typeface="Aptos"/>
+                <a:ea typeface="Aptos"/>
+                <a:cs typeface="Aptos"/>
+              </a:rPr>
+              <a:t>Holds USDC · enforces the state machine · emits events. It never sees a trade document.</a:t>
+            </a:r>
+          </a:p>
+        </p:txBody>
+      </p:sp>
+      <p:sp>
+        <p:nvSpPr>
+          <p:cNvPr id="59" name="right-head"/>
+          <p:cNvSpPr/>
+          <p:nvPr/>
+        </p:nvSpPr>
+        <p:spPr>
+          <a:xfrm>
+            <a:off x="7050000" y="2120000"/>
+            <a:ext cx="4608600" cy="260000"/>
           </a:xfrm>
           <a:prstGeom prst="rect">
             <a:avLst/>
@@ -24122,61 +24050,46 @@
           </a:ln>
         </p:spPr>
         <p:txBody>
-          <a:bodyPr lIns="0" tIns="0" rIns="0" bIns="0" anchor="t"/>
-          <a:lstStyle/>
-          <a:p>
-            <a:pPr algn="l">
-              <a:defRPr sz="938" b="0">
+          <a:bodyPr lIns="0" tIns="0" rIns="0" bIns="0" anchor="ctr" wrap="square">
+            <a:normAutofit/>
+          </a:bodyPr>
+          <a:lstStyle/>
+          <a:p>
+            <a:pPr algn="l"/>
+            <a:r>
+              <a:rPr sz="950" b="1">
                 <a:solidFill>
                   <a:srgbClr val="6B7280"/>
                 </a:solidFill>
                 <a:latin typeface="Aptos"/>
                 <a:ea typeface="Aptos"/>
                 <a:cs typeface="Aptos"/>
-              </a:defRPr>
-            </a:pPr>
-            <a:r>
-              <a:rPr sz="938" b="0">
-                <a:solidFill>
-                  <a:srgbClr val="6B7280"/>
-                </a:solidFill>
-                <a:latin typeface="Aptos"/>
-                <a:ea typeface="Aptos"/>
-                <a:cs typeface="Aptos"/>
-              </a:rPr>
-              <a:t>Invoice, packing list, transport document, certificate where needed.</a:t>
-            </a:r>
-          </a:p>
-        </p:txBody>
-      </p:sp>
-      <p:sp>
-        <p:nvSpPr>
-          <p:cNvPr id="18" name="Rectangle 17">
-            <a:extLst>
-              <a:ext uri="{FF2B5EF4-FFF2-40B4-BE49-F238E27FC236}">
-                <a16:creationId xmlns:a16="http://schemas.microsoft.com/office/drawing/2014/main" id="{99442F47-59E6-4BF6-BE5D-1ACAFA42D8C3}"/>
-              </a:ext>
-            </a:extLst>
-          </p:cNvPr>
-          <p:cNvSpPr>
-            <a:spLocks noGrp="1"/>
-          </p:cNvSpPr>
-          <p:nvPr/>
-        </p:nvSpPr>
-        <p:spPr>
-          <a:xfrm>
-            <a:off x="8953500" y="2686050"/>
-            <a:ext cx="2333625" cy="876300"/>
-          </a:xfrm>
-          <a:prstGeom prst="rect">
-            <a:avLst/>
-          </a:prstGeom>
-          <a:solidFill>
-            <a:srgbClr val="F4E8D2"/>
+              </a:rPr>
+              <a:t>DESIGN DECISIONS — WHY THE BUILD HOLDS</a:t>
+            </a:r>
+          </a:p>
+        </p:txBody>
+      </p:sp>
+      <p:sp>
+        <p:nvSpPr>
+          <p:cNvPr id="60" name="chip-card"/>
+          <p:cNvSpPr/>
+          <p:nvPr/>
+        </p:nvSpPr>
+        <p:spPr>
+          <a:xfrm>
+            <a:off x="7050000" y="2500000"/>
+            <a:ext cx="4608600" cy="815000"/>
+          </a:xfrm>
+          <a:prstGeom prst="rect">
+            <a:avLst/>
+          </a:prstGeom>
+          <a:solidFill>
+            <a:srgbClr val="FFFFFF"/>
           </a:solidFill>
           <a:ln w="9525">
             <a:solidFill>
-              <a:srgbClr val="C77D18"/>
+              <a:srgbClr val="D8D2C7"/>
             </a:solidFill>
             <a:prstDash val="solid"/>
           </a:ln>
@@ -24191,28 +24104,20 @@
       </p:sp>
       <p:sp>
         <p:nvSpPr>
-          <p:cNvPr id="19" name="Rectangle 18">
-            <a:extLst>
-              <a:ext uri="{FF2B5EF4-FFF2-40B4-BE49-F238E27FC236}">
-                <a16:creationId xmlns:a16="http://schemas.microsoft.com/office/drawing/2014/main" id="{4FC5EF57-433C-4671-B0BD-96513395E522}"/>
-              </a:ext>
-            </a:extLst>
-          </p:cNvPr>
-          <p:cNvSpPr>
-            <a:spLocks noGrp="1"/>
-          </p:cNvSpPr>
-          <p:nvPr/>
-        </p:nvSpPr>
-        <p:spPr>
-          <a:xfrm>
-            <a:off x="8953500" y="2686050"/>
-            <a:ext cx="57150" cy="876300"/>
-          </a:xfrm>
-          <a:prstGeom prst="rect">
-            <a:avLst/>
-          </a:prstGeom>
-          <a:solidFill>
-            <a:srgbClr val="C77D18"/>
+          <p:cNvPr id="61" name="chip-bar"/>
+          <p:cNvSpPr/>
+          <p:nvPr/>
+        </p:nvSpPr>
+        <p:spPr>
+          <a:xfrm>
+            <a:off x="7050000" y="2500000"/>
+            <a:ext cx="57150" cy="815000"/>
+          </a:xfrm>
+          <a:prstGeom prst="rect">
+            <a:avLst/>
+          </a:prstGeom>
+          <a:solidFill>
+            <a:srgbClr val="0B1B3A"/>
           </a:solidFill>
           <a:ln w="0">
             <a:solidFill>
@@ -24233,22 +24138,14 @@
       </p:sp>
       <p:sp>
         <p:nvSpPr>
-          <p:cNvPr id="20" name="Rectangle 19">
-            <a:extLst>
-              <a:ext uri="{FF2B5EF4-FFF2-40B4-BE49-F238E27FC236}">
-                <a16:creationId xmlns:a16="http://schemas.microsoft.com/office/drawing/2014/main" id="{F125EC64-7D55-4BBC-A80B-A135E0A91E34}"/>
-              </a:ext>
-            </a:extLst>
-          </p:cNvPr>
-          <p:cNvSpPr>
-            <a:spLocks noGrp="1"/>
-          </p:cNvSpPr>
-          <p:nvPr/>
-        </p:nvSpPr>
-        <p:spPr>
-          <a:xfrm>
-            <a:off x="9144000" y="2819400"/>
-            <a:ext cx="1905000" cy="209550"/>
+          <p:cNvPr id="62" name="chip-txt"/>
+          <p:cNvSpPr/>
+          <p:nvPr/>
+        </p:nvSpPr>
+        <p:spPr>
+          <a:xfrm>
+            <a:off x="7240500" y="2610000"/>
+            <a:ext cx="4268100" cy="635000"/>
           </a:xfrm>
           <a:prstGeom prst="rect">
             <a:avLst/>
@@ -24268,51 +24165,131 @@
           </a:ln>
         </p:spPr>
         <p:txBody>
-          <a:bodyPr lIns="0" tIns="0" rIns="0" bIns="0" anchor="t"/>
-          <a:lstStyle/>
+          <a:bodyPr lIns="0" tIns="0" rIns="0" bIns="0" anchor="ctr" wrap="square">
+            <a:normAutofit/>
+          </a:bodyPr>
+          <a:lstStyle/>
+          <a:p>
+            <a:pPr algn="l"/>
+            <a:r>
+              <a:rPr sz="1150" b="1">
+                <a:solidFill>
+                  <a:srgbClr val="0B1B3A"/>
+                </a:solidFill>
+                <a:latin typeface="Aptos"/>
+                <a:ea typeface="Aptos"/>
+                <a:cs typeface="Aptos"/>
+              </a:rPr>
+              <a:t>Narrow contract   </a:t>
+            </a:r>
+            <a:r>
+              <a:rPr sz="900" b="1">
+                <a:solidFill>
+                  <a:srgbClr val="0B1B3A"/>
+                </a:solidFill>
+                <a:latin typeface="Aptos"/>
+                <a:ea typeface="Aptos"/>
+                <a:cs typeface="Aptos"/>
+              </a:rPr>
+              <a:t>AP-1</a:t>
+            </a:r>
+          </a:p>
           <a:p>
             <a:pPr algn="l">
-              <a:defRPr sz="1200" b="1">
-                <a:solidFill>
-                  <a:srgbClr val="0B1B3A"/>
-                </a:solidFill>
-                <a:latin typeface="Aptos"/>
-                <a:ea typeface="Aptos"/>
-                <a:cs typeface="Aptos"/>
-              </a:defRPr>
+              <a:spcBef>
+                <a:spcPts val="300"/>
+              </a:spcBef>
             </a:pPr>
             <a:r>
-              <a:rPr sz="1200" b="1">
-                <a:solidFill>
-                  <a:srgbClr val="0B1B3A"/>
-                </a:solidFill>
-                <a:latin typeface="Aptos"/>
-                <a:ea typeface="Aptos"/>
-                <a:cs typeface="Aptos"/>
-              </a:rPr>
-              <a:t>4. Audit Trail</a:t>
-            </a:r>
-          </a:p>
-        </p:txBody>
-      </p:sp>
-      <p:sp>
-        <p:nvSpPr>
-          <p:cNvPr id="21" name="Rectangle 20">
-            <a:extLst>
-              <a:ext uri="{FF2B5EF4-FFF2-40B4-BE49-F238E27FC236}">
-                <a16:creationId xmlns:a16="http://schemas.microsoft.com/office/drawing/2014/main" id="{08A93EB0-FA1F-4BDB-923B-5E898D970B37}"/>
-              </a:ext>
-            </a:extLst>
-          </p:cNvPr>
-          <p:cNvSpPr>
-            <a:spLocks noGrp="1"/>
-          </p:cNvSpPr>
-          <p:nvPr/>
-        </p:nvSpPr>
-        <p:spPr>
-          <a:xfrm>
-            <a:off x="9144000" y="3086100"/>
-            <a:ext cx="1905000" cy="323850"/>
+              <a:rPr sz="950" b="0">
+                <a:solidFill>
+                  <a:srgbClr val="6B7280"/>
+                </a:solidFill>
+                <a:latin typeface="Aptos"/>
+                <a:ea typeface="Aptos"/>
+                <a:cs typeface="Aptos"/>
+              </a:rPr>
+              <a:t>On-chain code holds funds + state only — no document logic, no money math. Small attack surface, chain-portable.</a:t>
+            </a:r>
+          </a:p>
+        </p:txBody>
+      </p:sp>
+      <p:sp>
+        <p:nvSpPr>
+          <p:cNvPr id="63" name="chip-card"/>
+          <p:cNvSpPr/>
+          <p:nvPr/>
+        </p:nvSpPr>
+        <p:spPr>
+          <a:xfrm>
+            <a:off x="7050000" y="3410000"/>
+            <a:ext cx="4608600" cy="815000"/>
+          </a:xfrm>
+          <a:prstGeom prst="rect">
+            <a:avLst/>
+          </a:prstGeom>
+          <a:solidFill>
+            <a:srgbClr val="FFFFFF"/>
+          </a:solidFill>
+          <a:ln w="9525">
+            <a:solidFill>
+              <a:srgbClr val="D8D2C7"/>
+            </a:solidFill>
+            <a:prstDash val="solid"/>
+          </a:ln>
+        </p:spPr>
+        <p:txBody>
+          <a:bodyPr/>
+          <a:lstStyle/>
+          <a:p>
+            <a:endParaRPr/>
+          </a:p>
+        </p:txBody>
+      </p:sp>
+      <p:sp>
+        <p:nvSpPr>
+          <p:cNvPr id="64" name="chip-bar"/>
+          <p:cNvSpPr/>
+          <p:nvPr/>
+        </p:nvSpPr>
+        <p:spPr>
+          <a:xfrm>
+            <a:off x="7050000" y="3410000"/>
+            <a:ext cx="57150" cy="815000"/>
+          </a:xfrm>
+          <a:prstGeom prst="rect">
+            <a:avLst/>
+          </a:prstGeom>
+          <a:solidFill>
+            <a:srgbClr val="0E8C7F"/>
+          </a:solidFill>
+          <a:ln w="0">
+            <a:solidFill>
+              <a:srgbClr val="000000">
+                <a:alpha val="0"/>
+              </a:srgbClr>
+            </a:solidFill>
+            <a:prstDash val="solid"/>
+          </a:ln>
+        </p:spPr>
+        <p:txBody>
+          <a:bodyPr/>
+          <a:lstStyle/>
+          <a:p>
+            <a:endParaRPr/>
+          </a:p>
+        </p:txBody>
+      </p:sp>
+      <p:sp>
+        <p:nvSpPr>
+          <p:cNvPr id="65" name="chip-txt"/>
+          <p:cNvSpPr/>
+          <p:nvPr/>
+        </p:nvSpPr>
+        <p:spPr>
+          <a:xfrm>
+            <a:off x="7240500" y="3520000"/>
+            <a:ext cx="4268100" cy="635000"/>
           </a:xfrm>
           <a:prstGeom prst="rect">
             <a:avLst/>
@@ -24332,57 +24309,103 @@
           </a:ln>
         </p:spPr>
         <p:txBody>
-          <a:bodyPr lIns="0" tIns="0" rIns="0" bIns="0" anchor="t"/>
-          <a:lstStyle/>
+          <a:bodyPr lIns="0" tIns="0" rIns="0" bIns="0" anchor="ctr" wrap="square">
+            <a:normAutofit/>
+          </a:bodyPr>
+          <a:lstStyle/>
+          <a:p>
+            <a:pPr algn="l"/>
+            <a:r>
+              <a:rPr sz="1150" b="1">
+                <a:solidFill>
+                  <a:srgbClr val="0B1B3A"/>
+                </a:solidFill>
+                <a:latin typeface="Aptos"/>
+                <a:ea typeface="Aptos"/>
+                <a:cs typeface="Aptos"/>
+              </a:rPr>
+              <a:t>Permissionless release   </a:t>
+            </a:r>
+            <a:r>
+              <a:rPr sz="900" b="1">
+                <a:solidFill>
+                  <a:srgbClr val="0E8C7F"/>
+                </a:solidFill>
+                <a:latin typeface="Aptos"/>
+                <a:ea typeface="Aptos"/>
+                <a:cs typeface="Aptos"/>
+              </a:rPr>
+              <a:t>AP-7</a:t>
+            </a:r>
+          </a:p>
           <a:p>
             <a:pPr algn="l">
-              <a:defRPr sz="938" b="0">
+              <a:spcBef>
+                <a:spcPts val="300"/>
+              </a:spcBef>
+            </a:pPr>
+            <a:r>
+              <a:rPr sz="950" b="0">
                 <a:solidFill>
                   <a:srgbClr val="6B7280"/>
                 </a:solidFill>
                 <a:latin typeface="Aptos"/>
                 <a:ea typeface="Aptos"/>
                 <a:cs typeface="Aptos"/>
-              </a:defRPr>
-            </a:pPr>
-            <a:r>
-              <a:rPr sz="938" b="0">
-                <a:solidFill>
-                  <a:srgbClr val="6B7280"/>
-                </a:solidFill>
-                <a:latin typeface="Aptos"/>
-                <a:ea typeface="Aptos"/>
-                <a:cs typeface="Aptos"/>
-              </a:rPr>
-              <a:t>Reviewer notes, buyer notice, objection clock, release instruction.</a:t>
-            </a:r>
-          </a:p>
-        </p:txBody>
-      </p:sp>
-      <p:sp>
-        <p:nvSpPr>
-          <p:cNvPr id="22" name="Rectangle 21">
-            <a:extLst>
-              <a:ext uri="{FF2B5EF4-FFF2-40B4-BE49-F238E27FC236}">
-                <a16:creationId xmlns:a16="http://schemas.microsoft.com/office/drawing/2014/main" id="{9E6611C4-599F-454C-BBB0-8D4626054743}"/>
-              </a:ext>
-            </a:extLst>
-          </p:cNvPr>
-          <p:cNvSpPr>
-            <a:spLocks noGrp="1"/>
-          </p:cNvSpPr>
-          <p:nvPr/>
-        </p:nvSpPr>
-        <p:spPr>
-          <a:xfrm>
-            <a:off x="3028950" y="3114675"/>
-            <a:ext cx="361950" cy="19050"/>
-          </a:xfrm>
-          <a:prstGeom prst="rect">
-            <a:avLst/>
-          </a:prstGeom>
-          <a:solidFill>
-            <a:srgbClr val="6B7280"/>
+              </a:rPr>
+              <a:t>Release isn’t gated on our key — a cleared seller can always be paid. Liveness without trusting the operator.</a:t>
+            </a:r>
+          </a:p>
+        </p:txBody>
+      </p:sp>
+      <p:sp>
+        <p:nvSpPr>
+          <p:cNvPr id="66" name="chip-card"/>
+          <p:cNvSpPr/>
+          <p:nvPr/>
+        </p:nvSpPr>
+        <p:spPr>
+          <a:xfrm>
+            <a:off x="7050000" y="4320000"/>
+            <a:ext cx="4608600" cy="815000"/>
+          </a:xfrm>
+          <a:prstGeom prst="rect">
+            <a:avLst/>
+          </a:prstGeom>
+          <a:solidFill>
+            <a:srgbClr val="FFFFFF"/>
+          </a:solidFill>
+          <a:ln w="9525">
+            <a:solidFill>
+              <a:srgbClr val="D8D2C7"/>
+            </a:solidFill>
+            <a:prstDash val="solid"/>
+          </a:ln>
+        </p:spPr>
+        <p:txBody>
+          <a:bodyPr/>
+          <a:lstStyle/>
+          <a:p>
+            <a:endParaRPr/>
+          </a:p>
+        </p:txBody>
+      </p:sp>
+      <p:sp>
+        <p:nvSpPr>
+          <p:cNvPr id="67" name="chip-bar"/>
+          <p:cNvSpPr/>
+          <p:nvPr/>
+        </p:nvSpPr>
+        <p:spPr>
+          <a:xfrm>
+            <a:off x="7050000" y="4320000"/>
+            <a:ext cx="57150" cy="815000"/>
+          </a:xfrm>
+          <a:prstGeom prst="rect">
+            <a:avLst/>
+          </a:prstGeom>
+          <a:solidFill>
+            <a:srgbClr val="1F6FB2"/>
           </a:solidFill>
           <a:ln w="0">
             <a:solidFill>
@@ -24403,28 +24426,22 @@
       </p:sp>
       <p:sp>
         <p:nvSpPr>
-          <p:cNvPr id="23" name="Rectangle 22">
-            <a:extLst>
-              <a:ext uri="{FF2B5EF4-FFF2-40B4-BE49-F238E27FC236}">
-                <a16:creationId xmlns:a16="http://schemas.microsoft.com/office/drawing/2014/main" id="{D01D796B-F4AC-47A2-945A-21EDBEE54B53}"/>
-              </a:ext>
-            </a:extLst>
-          </p:cNvPr>
-          <p:cNvSpPr>
-            <a:spLocks noGrp="1"/>
-          </p:cNvSpPr>
-          <p:nvPr/>
-        </p:nvSpPr>
-        <p:spPr>
-          <a:xfrm>
-            <a:off x="5791200" y="3114675"/>
-            <a:ext cx="361950" cy="19050"/>
-          </a:xfrm>
-          <a:prstGeom prst="rect">
-            <a:avLst/>
-          </a:prstGeom>
-          <a:solidFill>
-            <a:srgbClr val="6B7280"/>
+          <p:cNvPr id="68" name="chip-txt"/>
+          <p:cNvSpPr/>
+          <p:nvPr/>
+        </p:nvSpPr>
+        <p:spPr>
+          <a:xfrm>
+            <a:off x="7240500" y="4430000"/>
+            <a:ext cx="4268100" cy="635000"/>
+          </a:xfrm>
+          <a:prstGeom prst="rect">
+            <a:avLst/>
+          </a:prstGeom>
+          <a:solidFill>
+            <a:srgbClr val="000000">
+              <a:alpha val="0"/>
+            </a:srgbClr>
           </a:solidFill>
           <a:ln w="0">
             <a:solidFill>
@@ -24436,6 +24453,80 @@
           </a:ln>
         </p:spPr>
         <p:txBody>
+          <a:bodyPr lIns="0" tIns="0" rIns="0" bIns="0" anchor="ctr" wrap="square">
+            <a:normAutofit/>
+          </a:bodyPr>
+          <a:lstStyle/>
+          <a:p>
+            <a:pPr algn="l"/>
+            <a:r>
+              <a:rPr sz="1150" b="1">
+                <a:solidFill>
+                  <a:srgbClr val="0B1B3A"/>
+                </a:solidFill>
+                <a:latin typeface="Aptos"/>
+                <a:ea typeface="Aptos"/>
+                <a:cs typeface="Aptos"/>
+              </a:rPr>
+              <a:t>Audit around every action   </a:t>
+            </a:r>
+            <a:r>
+              <a:rPr sz="900" b="1">
+                <a:solidFill>
+                  <a:srgbClr val="1F6FB2"/>
+                </a:solidFill>
+                <a:latin typeface="Aptos"/>
+                <a:ea typeface="Aptos"/>
+                <a:cs typeface="Aptos"/>
+              </a:rPr>
+              <a:t>AP-4</a:t>
+            </a:r>
+          </a:p>
+          <a:p>
+            <a:pPr algn="l">
+              <a:spcBef>
+                <a:spcPts val="300"/>
+              </a:spcBef>
+            </a:pPr>
+            <a:r>
+              <a:rPr sz="950" b="0">
+                <a:solidFill>
+                  <a:srgbClr val="6B7280"/>
+                </a:solidFill>
+                <a:latin typeface="Aptos"/>
+                <a:ea typeface="Aptos"/>
+                <a:cs typeface="Aptos"/>
+              </a:rPr>
+              <a:t>Intent logged before the tx, reconciliation after. The ledger — not the chain — is the source of truth.</a:t>
+            </a:r>
+          </a:p>
+        </p:txBody>
+      </p:sp>
+      <p:sp>
+        <p:nvSpPr>
+          <p:cNvPr id="69" name="chip-card"/>
+          <p:cNvSpPr/>
+          <p:nvPr/>
+        </p:nvSpPr>
+        <p:spPr>
+          <a:xfrm>
+            <a:off x="7050000" y="5230000"/>
+            <a:ext cx="4608600" cy="815000"/>
+          </a:xfrm>
+          <a:prstGeom prst="rect">
+            <a:avLst/>
+          </a:prstGeom>
+          <a:solidFill>
+            <a:srgbClr val="FFFFFF"/>
+          </a:solidFill>
+          <a:ln w="9525">
+            <a:solidFill>
+              <a:srgbClr val="D8D2C7"/>
+            </a:solidFill>
+            <a:prstDash val="solid"/>
+          </a:ln>
+        </p:spPr>
+        <p:txBody>
           <a:bodyPr/>
           <a:lstStyle/>
           <a:p>
@@ -24445,28 +24536,20 @@
       </p:sp>
       <p:sp>
         <p:nvSpPr>
-          <p:cNvPr id="24" name="Rectangle 23">
-            <a:extLst>
-              <a:ext uri="{FF2B5EF4-FFF2-40B4-BE49-F238E27FC236}">
-                <a16:creationId xmlns:a16="http://schemas.microsoft.com/office/drawing/2014/main" id="{014A901D-02FE-4794-A58A-373F35120E20}"/>
-              </a:ext>
-            </a:extLst>
-          </p:cNvPr>
-          <p:cNvSpPr>
-            <a:spLocks noGrp="1"/>
-          </p:cNvSpPr>
-          <p:nvPr/>
-        </p:nvSpPr>
-        <p:spPr>
-          <a:xfrm>
-            <a:off x="8553450" y="3114675"/>
-            <a:ext cx="361950" cy="19050"/>
-          </a:xfrm>
-          <a:prstGeom prst="rect">
-            <a:avLst/>
-          </a:prstGeom>
-          <a:solidFill>
-            <a:srgbClr val="6B7280"/>
+          <p:cNvPr id="70" name="chip-bar"/>
+          <p:cNvSpPr/>
+          <p:nvPr/>
+        </p:nvSpPr>
+        <p:spPr>
+          <a:xfrm>
+            <a:off x="7050000" y="5230000"/>
+            <a:ext cx="57150" cy="815000"/>
+          </a:xfrm>
+          <a:prstGeom prst="rect">
+            <a:avLst/>
+          </a:prstGeom>
+          <a:solidFill>
+            <a:srgbClr val="C77D18"/>
           </a:solidFill>
           <a:ln w="0">
             <a:solidFill>
@@ -24487,62 +24570,14 @@
       </p:sp>
       <p:sp>
         <p:nvSpPr>
-          <p:cNvPr id="25" name="Rectangle 24">
-            <a:extLst>
-              <a:ext uri="{FF2B5EF4-FFF2-40B4-BE49-F238E27FC236}">
-                <a16:creationId xmlns:a16="http://schemas.microsoft.com/office/drawing/2014/main" id="{F943F194-E45D-40B4-86E8-66C1C36D5C67}"/>
-              </a:ext>
-            </a:extLst>
-          </p:cNvPr>
-          <p:cNvSpPr>
-            <a:spLocks noGrp="1"/>
-          </p:cNvSpPr>
-          <p:nvPr/>
-        </p:nvSpPr>
-        <p:spPr>
-          <a:xfrm>
-            <a:off x="1047750" y="4171950"/>
-            <a:ext cx="4362450" cy="895350"/>
-          </a:xfrm>
-          <a:prstGeom prst="rect">
-            <a:avLst/>
-          </a:prstGeom>
-          <a:solidFill>
-            <a:srgbClr val="FFFFFF"/>
-          </a:solidFill>
-          <a:ln w="9525">
-            <a:solidFill>
-              <a:srgbClr val="D8D2C7"/>
-            </a:solidFill>
-            <a:prstDash val="solid"/>
-          </a:ln>
-        </p:spPr>
-        <p:txBody>
-          <a:bodyPr/>
-          <a:lstStyle/>
-          <a:p>
-            <a:endParaRPr/>
-          </a:p>
-        </p:txBody>
-      </p:sp>
-      <p:sp>
-        <p:nvSpPr>
-          <p:cNvPr id="26" name="Rectangle 25">
-            <a:extLst>
-              <a:ext uri="{FF2B5EF4-FFF2-40B4-BE49-F238E27FC236}">
-                <a16:creationId xmlns:a16="http://schemas.microsoft.com/office/drawing/2014/main" id="{72F4E5C7-1612-41BF-9EDD-8B3932341C6C}"/>
-              </a:ext>
-            </a:extLst>
-          </p:cNvPr>
-          <p:cNvSpPr>
-            <a:spLocks noGrp="1"/>
-          </p:cNvSpPr>
-          <p:nvPr/>
-        </p:nvSpPr>
-        <p:spPr>
-          <a:xfrm>
-            <a:off x="1276350" y="4362450"/>
-            <a:ext cx="2476500" cy="209550"/>
+          <p:cNvPr id="71" name="chip-txt"/>
+          <p:cNvSpPr/>
+          <p:nvPr/>
+        </p:nvSpPr>
+        <p:spPr>
+          <a:xfrm>
+            <a:off x="7240500" y="5340000"/>
+            <a:ext cx="4268100" cy="635000"/>
           </a:xfrm>
           <a:prstGeom prst="rect">
             <a:avLst/>
@@ -24562,51 +24597,65 @@
           </a:ln>
         </p:spPr>
         <p:txBody>
-          <a:bodyPr lIns="0" tIns="0" rIns="0" bIns="0" anchor="t"/>
-          <a:lstStyle/>
+          <a:bodyPr lIns="0" tIns="0" rIns="0" bIns="0" anchor="ctr" wrap="square">
+            <a:normAutofit/>
+          </a:bodyPr>
+          <a:lstStyle/>
+          <a:p>
+            <a:pPr algn="l"/>
+            <a:r>
+              <a:rPr sz="1150" b="1">
+                <a:solidFill>
+                  <a:srgbClr val="0B1B3A"/>
+                </a:solidFill>
+                <a:latin typeface="Aptos"/>
+                <a:ea typeface="Aptos"/>
+                <a:cs typeface="Aptos"/>
+              </a:rPr>
+              <a:t>Money in code, human above the line   </a:t>
+            </a:r>
+            <a:r>
+              <a:rPr sz="900" b="1">
+                <a:solidFill>
+                  <a:srgbClr val="C77D18"/>
+                </a:solidFill>
+                <a:latin typeface="Aptos"/>
+                <a:ea typeface="Aptos"/>
+                <a:cs typeface="Aptos"/>
+              </a:rPr>
+              <a:t>AP-5 / 7</a:t>
+            </a:r>
+          </a:p>
           <a:p>
             <a:pPr algn="l">
-              <a:defRPr sz="1350" b="1">
-                <a:solidFill>
-                  <a:srgbClr val="0B1B3A"/>
-                </a:solidFill>
-                <a:latin typeface="Aptos"/>
-                <a:ea typeface="Aptos"/>
-                <a:cs typeface="Aptos"/>
-              </a:defRPr>
+              <a:spcBef>
+                <a:spcPts val="300"/>
+              </a:spcBef>
             </a:pPr>
             <a:r>
-              <a:rPr sz="1350" b="1">
-                <a:solidFill>
-                  <a:srgbClr val="0B1B3A"/>
-                </a:solidFill>
-                <a:latin typeface="Aptos"/>
-                <a:ea typeface="Aptos"/>
-                <a:cs typeface="Aptos"/>
-              </a:rPr>
-              <a:t>On-chain state stays narrow</a:t>
-            </a:r>
-          </a:p>
-        </p:txBody>
-      </p:sp>
-      <p:sp>
-        <p:nvSpPr>
-          <p:cNvPr id="27" name="Rectangle 26">
-            <a:extLst>
-              <a:ext uri="{FF2B5EF4-FFF2-40B4-BE49-F238E27FC236}">
-                <a16:creationId xmlns:a16="http://schemas.microsoft.com/office/drawing/2014/main" id="{7B4A9006-EC23-4449-903E-94443393FC3D}"/>
-              </a:ext>
-            </a:extLst>
-          </p:cNvPr>
-          <p:cNvSpPr>
-            <a:spLocks noGrp="1"/>
-          </p:cNvSpPr>
-          <p:nvPr/>
-        </p:nvSpPr>
-        <p:spPr>
-          <a:xfrm>
-            <a:off x="1276350" y="4667250"/>
-            <a:ext cx="3638550" cy="228600"/>
+              <a:rPr sz="950" b="0">
+                <a:solidFill>
+                  <a:srgbClr val="6B7280"/>
+                </a:solidFill>
+                <a:latin typeface="Aptos"/>
+                <a:ea typeface="Aptos"/>
+                <a:cs typeface="Aptos"/>
+              </a:rPr>
+              <a:t>All arithmetic is deterministic code; anything outside the autonomy thresholds escalates to a human sign-off.</a:t>
+            </a:r>
+          </a:p>
+        </p:txBody>
+      </p:sp>
+      <p:sp>
+        <p:nvSpPr>
+          <p:cNvPr id="72" name="pagenum"/>
+          <p:cNvSpPr/>
+          <p:nvPr/>
+        </p:nvSpPr>
+        <p:spPr>
+          <a:xfrm>
+            <a:off x="11106150" y="6438900"/>
+            <a:ext cx="552450" cy="228600"/>
           </a:xfrm>
           <a:prstGeom prst="rect">
             <a:avLst/>
@@ -24626,259 +24675,20 @@
           </a:ln>
         </p:spPr>
         <p:txBody>
-          <a:bodyPr lIns="0" tIns="0" rIns="0" bIns="0" anchor="t"/>
-          <a:lstStyle/>
-          <a:p>
-            <a:pPr algn="l">
-              <a:defRPr sz="1200" b="1">
-                <a:solidFill>
-                  <a:srgbClr val="0E8C7F"/>
-                </a:solidFill>
-                <a:latin typeface="Aptos"/>
-                <a:ea typeface="Aptos"/>
-                <a:cs typeface="Aptos"/>
-              </a:defRPr>
-            </a:pPr>
-            <a:r>
-              <a:rPr sz="1200" b="1">
-                <a:solidFill>
-                  <a:srgbClr val="0E8C7F"/>
-                </a:solidFill>
-                <a:latin typeface="Aptos"/>
-                <a:ea typeface="Aptos"/>
-                <a:cs typeface="Aptos"/>
-              </a:rPr>
-              <a:t>Created -&gt; Funded -&gt; ReleasePending -&gt; Released / Refunded / Disputed</a:t>
-            </a:r>
-          </a:p>
-        </p:txBody>
-      </p:sp>
-      <p:sp>
-        <p:nvSpPr>
-          <p:cNvPr id="28" name="Rectangle 27">
-            <a:extLst>
-              <a:ext uri="{FF2B5EF4-FFF2-40B4-BE49-F238E27FC236}">
-                <a16:creationId xmlns:a16="http://schemas.microsoft.com/office/drawing/2014/main" id="{E1740E81-F192-41AD-83C2-2627500D4C12}"/>
-              </a:ext>
-            </a:extLst>
-          </p:cNvPr>
-          <p:cNvSpPr>
-            <a:spLocks noGrp="1"/>
-          </p:cNvSpPr>
-          <p:nvPr/>
-        </p:nvSpPr>
-        <p:spPr>
-          <a:xfrm>
-            <a:off x="5829300" y="4171950"/>
-            <a:ext cx="4362450" cy="895350"/>
-          </a:xfrm>
-          <a:prstGeom prst="rect">
-            <a:avLst/>
-          </a:prstGeom>
-          <a:solidFill>
-            <a:srgbClr val="FFFFFF"/>
-          </a:solidFill>
-          <a:ln w="9525">
-            <a:solidFill>
-              <a:srgbClr val="D8D2C7"/>
-            </a:solidFill>
-            <a:prstDash val="solid"/>
-          </a:ln>
-        </p:spPr>
-        <p:txBody>
-          <a:bodyPr/>
-          <a:lstStyle/>
-          <a:p>
-            <a:endParaRPr/>
-          </a:p>
-        </p:txBody>
-      </p:sp>
-      <p:sp>
-        <p:nvSpPr>
-          <p:cNvPr id="29" name="Rectangle 28">
-            <a:extLst>
-              <a:ext uri="{FF2B5EF4-FFF2-40B4-BE49-F238E27FC236}">
-                <a16:creationId xmlns:a16="http://schemas.microsoft.com/office/drawing/2014/main" id="{EFA59945-495B-4304-9CAF-99EC9EC01D7C}"/>
-              </a:ext>
-            </a:extLst>
-          </p:cNvPr>
-          <p:cNvSpPr>
-            <a:spLocks noGrp="1"/>
-          </p:cNvSpPr>
-          <p:nvPr/>
-        </p:nvSpPr>
-        <p:spPr>
-          <a:xfrm>
-            <a:off x="6057900" y="4362450"/>
-            <a:ext cx="3048000" cy="209550"/>
-          </a:xfrm>
-          <a:prstGeom prst="rect">
-            <a:avLst/>
-          </a:prstGeom>
-          <a:solidFill>
-            <a:srgbClr val="000000">
-              <a:alpha val="0"/>
-            </a:srgbClr>
-          </a:solidFill>
-          <a:ln w="0">
-            <a:solidFill>
-              <a:srgbClr val="000000">
-                <a:alpha val="0"/>
-              </a:srgbClr>
-            </a:solidFill>
-            <a:prstDash val="solid"/>
-          </a:ln>
-        </p:spPr>
-        <p:txBody>
-          <a:bodyPr lIns="0" tIns="0" rIns="0" bIns="0" anchor="t"/>
-          <a:lstStyle/>
-          <a:p>
-            <a:pPr algn="l">
-              <a:defRPr sz="1350" b="1">
-                <a:solidFill>
-                  <a:srgbClr val="0B1B3A"/>
-                </a:solidFill>
-                <a:latin typeface="Aptos"/>
-                <a:ea typeface="Aptos"/>
-                <a:cs typeface="Aptos"/>
-              </a:defRPr>
-            </a:pPr>
-            <a:r>
-              <a:rPr sz="1350" b="1">
-                <a:solidFill>
-                  <a:srgbClr val="0B1B3A"/>
-                </a:solidFill>
-                <a:latin typeface="Aptos"/>
-                <a:ea typeface="Aptos"/>
-                <a:cs typeface="Aptos"/>
-              </a:rPr>
-              <a:t>Off-chain review carries the nuance</a:t>
-            </a:r>
-          </a:p>
-        </p:txBody>
-      </p:sp>
-      <p:sp>
-        <p:nvSpPr>
-          <p:cNvPr id="30" name="Rectangle 29">
-            <a:extLst>
-              <a:ext uri="{FF2B5EF4-FFF2-40B4-BE49-F238E27FC236}">
-                <a16:creationId xmlns:a16="http://schemas.microsoft.com/office/drawing/2014/main" id="{30A092C1-077B-4627-BA3A-47BDFC9888E6}"/>
-              </a:ext>
-            </a:extLst>
-          </p:cNvPr>
-          <p:cNvSpPr>
-            <a:spLocks noGrp="1"/>
-          </p:cNvSpPr>
-          <p:nvPr/>
-        </p:nvSpPr>
-        <p:spPr>
-          <a:xfrm>
-            <a:off x="6057900" y="4667250"/>
-            <a:ext cx="3562350" cy="361950"/>
-          </a:xfrm>
-          <a:prstGeom prst="rect">
-            <a:avLst/>
-          </a:prstGeom>
-          <a:solidFill>
-            <a:srgbClr val="000000">
-              <a:alpha val="0"/>
-            </a:srgbClr>
-          </a:solidFill>
-          <a:ln w="0">
-            <a:solidFill>
-              <a:srgbClr val="000000">
-                <a:alpha val="0"/>
-              </a:srgbClr>
-            </a:solidFill>
-            <a:prstDash val="solid"/>
-          </a:ln>
-        </p:spPr>
-        <p:txBody>
-          <a:bodyPr lIns="0" tIns="0" rIns="0" bIns="0" anchor="t"/>
-          <a:lstStyle/>
-          <a:p>
-            <a:pPr algn="l">
-              <a:defRPr sz="1125" b="0">
+          <a:bodyPr lIns="0" tIns="0" rIns="0" bIns="0" anchor="t" wrap="square">
+            <a:normAutofit/>
+          </a:bodyPr>
+          <a:lstStyle/>
+          <a:p>
+            <a:pPr algn="r"/>
+            <a:r>
+              <a:rPr sz="900" b="1">
                 <a:solidFill>
                   <a:srgbClr val="6B7280"/>
                 </a:solidFill>
                 <a:latin typeface="Aptos"/>
                 <a:ea typeface="Aptos"/>
                 <a:cs typeface="Aptos"/>
-              </a:defRPr>
-            </a:pPr>
-            <a:r>
-              <a:rPr sz="1125" b="0">
-                <a:solidFill>
-                  <a:srgbClr val="6B7280"/>
-                </a:solidFill>
-                <a:latin typeface="Aptos"/>
-                <a:ea typeface="Aptos"/>
-                <a:cs typeface="Aptos"/>
-              </a:rPr>
-              <a:t>Document intake, apparent compliance, sanctions checks, buyer objection validity, examiner escalation.</a:t>
-            </a:r>
-          </a:p>
-        </p:txBody>
-      </p:sp>
-      <p:sp>
-        <p:nvSpPr>
-          <p:cNvPr id="32" name="Rectangle 31">
-            <a:extLst>
-              <a:ext uri="{FF2B5EF4-FFF2-40B4-BE49-F238E27FC236}">
-                <a16:creationId xmlns:a16="http://schemas.microsoft.com/office/drawing/2014/main" id="{B255769E-B3A0-449A-AF4F-F8182976ED5B}"/>
-              </a:ext>
-            </a:extLst>
-          </p:cNvPr>
-          <p:cNvSpPr>
-            <a:spLocks noGrp="1"/>
-          </p:cNvSpPr>
-          <p:nvPr/>
-        </p:nvSpPr>
-        <p:spPr>
-          <a:xfrm>
-            <a:off x="11106150" y="6438900"/>
-            <a:ext cx="552450" cy="228600"/>
-          </a:xfrm>
-          <a:prstGeom prst="rect">
-            <a:avLst/>
-          </a:prstGeom>
-          <a:solidFill>
-            <a:srgbClr val="000000">
-              <a:alpha val="0"/>
-            </a:srgbClr>
-          </a:solidFill>
-          <a:ln w="0">
-            <a:solidFill>
-              <a:srgbClr val="000000">
-                <a:alpha val="0"/>
-              </a:srgbClr>
-            </a:solidFill>
-            <a:prstDash val="solid"/>
-          </a:ln>
-        </p:spPr>
-        <p:txBody>
-          <a:bodyPr lIns="0" tIns="0" rIns="0" bIns="0" anchor="t"/>
-          <a:lstStyle/>
-          <a:p>
-            <a:pPr algn="r">
-              <a:defRPr sz="900" b="1">
-                <a:solidFill>
-                  <a:srgbClr val="6B7280"/>
-                </a:solidFill>
-                <a:latin typeface="Aptos"/>
-                <a:ea typeface="Aptos"/>
-                <a:cs typeface="Aptos"/>
-              </a:defRPr>
-            </a:pPr>
-            <a:r>
-              <a:rPr sz="900" b="1">
-                <a:solidFill>
-                  <a:srgbClr val="6B7280"/>
-                </a:solidFill>
-                <a:latin typeface="Aptos"/>
-                <a:ea typeface="Aptos"/>
-                <a:cs typeface="Aptos"/>
               </a:rPr>
               <a:t>05</a:t>
             </a:r>
@@ -24886,11 +24696,6 @@
         </p:txBody>
       </p:sp>
     </p:spTree>
-    <p:extLst>
-      <p:ext uri="{BB962C8B-B14F-4D97-AF65-F5344CB8AC3E}">
-        <p14:creationId xmlns:p14="http://schemas.microsoft.com/office/powerpoint/2010/main" val="1005415741"/>
-      </p:ext>
-    </p:extLst>
   </p:cSld>
   <p:clrMapOvr>
     <a:masterClrMapping/>

</xml_diff>